<commit_message>
Change the powerpoint. Removed some images
</commit_message>
<xml_diff>
--- a/slides/rideshare_presentation.pptx
+++ b/slides/rideshare_presentation.pptx
@@ -305,7 +305,7 @@
           <a:p>
             <a:fld id="{5BCAD085-E8A6-8845-BD4E-CB4CCA059FC4}" type="datetimeFigureOut">
               <a:rPr lang="en-US" smtClean="0"/>
-              <a:t>4/27/2026</a:t>
+              <a:t>4/29/2026</a:t>
             </a:fld>
             <a:endParaRPr lang="en-US"/>
           </a:p>
@@ -572,7 +572,7 @@
           <a:p>
             <a:fld id="{5BCAD085-E8A6-8845-BD4E-CB4CCA059FC4}" type="datetimeFigureOut">
               <a:rPr lang="en-US" smtClean="0"/>
-              <a:t>4/27/2026</a:t>
+              <a:t>4/29/2026</a:t>
             </a:fld>
             <a:endParaRPr lang="en-US"/>
           </a:p>
@@ -803,7 +803,7 @@
           <a:p>
             <a:fld id="{5BCAD085-E8A6-8845-BD4E-CB4CCA059FC4}" type="datetimeFigureOut">
               <a:rPr lang="en-US" smtClean="0"/>
-              <a:t>4/27/2026</a:t>
+              <a:t>4/29/2026</a:t>
             </a:fld>
             <a:endParaRPr lang="en-US"/>
           </a:p>
@@ -1113,7 +1113,7 @@
           <a:p>
             <a:fld id="{5BCAD085-E8A6-8845-BD4E-CB4CCA059FC4}" type="datetimeFigureOut">
               <a:rPr lang="en-US" smtClean="0"/>
-              <a:t>4/27/2026</a:t>
+              <a:t>4/29/2026</a:t>
             </a:fld>
             <a:endParaRPr lang="en-US"/>
           </a:p>
@@ -1586,7 +1586,7 @@
           <a:p>
             <a:fld id="{5BCAD085-E8A6-8845-BD4E-CB4CCA059FC4}" type="datetimeFigureOut">
               <a:rPr lang="en-US" smtClean="0"/>
-              <a:t>4/27/2026</a:t>
+              <a:t>4/29/2026</a:t>
             </a:fld>
             <a:endParaRPr lang="en-US"/>
           </a:p>
@@ -2133,7 +2133,7 @@
           <a:p>
             <a:fld id="{5BCAD085-E8A6-8845-BD4E-CB4CCA059FC4}" type="datetimeFigureOut">
               <a:rPr lang="en-US" smtClean="0"/>
-              <a:t>4/27/2026</a:t>
+              <a:t>4/29/2026</a:t>
             </a:fld>
             <a:endParaRPr lang="en-US"/>
           </a:p>
@@ -2907,7 +2907,7 @@
           <a:p>
             <a:fld id="{5BCAD085-E8A6-8845-BD4E-CB4CCA059FC4}" type="datetimeFigureOut">
               <a:rPr lang="en-US" smtClean="0"/>
-              <a:t>4/27/2026</a:t>
+              <a:t>4/29/2026</a:t>
             </a:fld>
             <a:endParaRPr lang="en-US"/>
           </a:p>
@@ -3082,7 +3082,7 @@
           <a:p>
             <a:fld id="{5BCAD085-E8A6-8845-BD4E-CB4CCA059FC4}" type="datetimeFigureOut">
               <a:rPr lang="en-US" smtClean="0"/>
-              <a:t>4/27/2026</a:t>
+              <a:t>4/29/2026</a:t>
             </a:fld>
             <a:endParaRPr lang="en-US"/>
           </a:p>
@@ -3305,7 +3305,7 @@
           <a:p>
             <a:fld id="{5BCAD085-E8A6-8845-BD4E-CB4CCA059FC4}" type="datetimeFigureOut">
               <a:rPr lang="en-US" smtClean="0"/>
-              <a:t>4/27/2026</a:t>
+              <a:t>4/29/2026</a:t>
             </a:fld>
             <a:endParaRPr lang="en-US"/>
           </a:p>
@@ -3485,7 +3485,7 @@
           <a:p>
             <a:fld id="{5BCAD085-E8A6-8845-BD4E-CB4CCA059FC4}" type="datetimeFigureOut">
               <a:rPr lang="en-US" smtClean="0"/>
-              <a:t>4/27/2026</a:t>
+              <a:t>4/29/2026</a:t>
             </a:fld>
             <a:endParaRPr lang="en-US"/>
           </a:p>
@@ -3774,7 +3774,7 @@
           <a:p>
             <a:fld id="{5BCAD085-E8A6-8845-BD4E-CB4CCA059FC4}" type="datetimeFigureOut">
               <a:rPr lang="en-US" smtClean="0"/>
-              <a:t>4/27/2026</a:t>
+              <a:t>4/29/2026</a:t>
             </a:fld>
             <a:endParaRPr lang="en-US"/>
           </a:p>
@@ -4016,7 +4016,7 @@
           <a:p>
             <a:fld id="{5BCAD085-E8A6-8845-BD4E-CB4CCA059FC4}" type="datetimeFigureOut">
               <a:rPr lang="en-US" smtClean="0"/>
-              <a:t>4/27/2026</a:t>
+              <a:t>4/29/2026</a:t>
             </a:fld>
             <a:endParaRPr lang="en-US"/>
           </a:p>
@@ -4395,7 +4395,7 @@
           <a:p>
             <a:fld id="{5BCAD085-E8A6-8845-BD4E-CB4CCA059FC4}" type="datetimeFigureOut">
               <a:rPr lang="en-US" smtClean="0"/>
-              <a:t>4/27/2026</a:t>
+              <a:t>4/29/2026</a:t>
             </a:fld>
             <a:endParaRPr lang="en-US"/>
           </a:p>
@@ -4513,7 +4513,7 @@
           <a:p>
             <a:fld id="{5BCAD085-E8A6-8845-BD4E-CB4CCA059FC4}" type="datetimeFigureOut">
               <a:rPr lang="en-US" smtClean="0"/>
-              <a:t>4/27/2026</a:t>
+              <a:t>4/29/2026</a:t>
             </a:fld>
             <a:endParaRPr lang="en-US"/>
           </a:p>
@@ -4608,7 +4608,7 @@
           <a:p>
             <a:fld id="{5BCAD085-E8A6-8845-BD4E-CB4CCA059FC4}" type="datetimeFigureOut">
               <a:rPr lang="en-US" smtClean="0"/>
-              <a:t>4/27/2026</a:t>
+              <a:t>4/29/2026</a:t>
             </a:fld>
             <a:endParaRPr lang="en-US"/>
           </a:p>
@@ -4857,7 +4857,7 @@
           <a:p>
             <a:fld id="{5BCAD085-E8A6-8845-BD4E-CB4CCA059FC4}" type="datetimeFigureOut">
               <a:rPr lang="en-US" smtClean="0"/>
-              <a:t>4/27/2026</a:t>
+              <a:t>4/29/2026</a:t>
             </a:fld>
             <a:endParaRPr lang="en-US"/>
           </a:p>
@@ -5114,7 +5114,7 @@
           <a:p>
             <a:fld id="{5BCAD085-E8A6-8845-BD4E-CB4CCA059FC4}" type="datetimeFigureOut">
               <a:rPr lang="en-US" smtClean="0"/>
-              <a:t>4/27/2026</a:t>
+              <a:t>4/29/2026</a:t>
             </a:fld>
             <a:endParaRPr lang="en-US"/>
           </a:p>
@@ -5357,7 +5357,7 @@
           <a:p>
             <a:fld id="{5BCAD085-E8A6-8845-BD4E-CB4CCA059FC4}" type="datetimeFigureOut">
               <a:rPr lang="en-US" smtClean="0"/>
-              <a:t>4/27/2026</a:t>
+              <a:t>4/29/2026</a:t>
             </a:fld>
             <a:endParaRPr lang="en-US"/>
           </a:p>
@@ -5892,66 +5892,6 @@
           </a:p>
         </p:txBody>
       </p:sp>
-      <p:pic>
-        <p:nvPicPr>
-          <p:cNvPr id="5" name="Picture 4">
-            <a:extLst>
-              <a:ext uri="{FF2B5EF4-FFF2-40B4-BE49-F238E27FC236}">
-                <a16:creationId xmlns:a16="http://schemas.microsoft.com/office/drawing/2014/main" id="{2A0B3FB3-792D-668F-DF37-F363F0834133}"/>
-              </a:ext>
-            </a:extLst>
-          </p:cNvPr>
-          <p:cNvPicPr>
-            <a:picLocks noChangeAspect="1"/>
-          </p:cNvPicPr>
-          <p:nvPr/>
-        </p:nvPicPr>
-        <p:blipFill>
-          <a:blip r:embed="rId2"/>
-          <a:stretch>
-            <a:fillRect/>
-          </a:stretch>
-        </p:blipFill>
-        <p:spPr>
-          <a:xfrm>
-            <a:off x="157806" y="3660550"/>
-            <a:ext cx="4381092" cy="2603090"/>
-          </a:xfrm>
-          <a:prstGeom prst="rect">
-            <a:avLst/>
-          </a:prstGeom>
-        </p:spPr>
-      </p:pic>
-      <p:pic>
-        <p:nvPicPr>
-          <p:cNvPr id="7" name="Picture 6">
-            <a:extLst>
-              <a:ext uri="{FF2B5EF4-FFF2-40B4-BE49-F238E27FC236}">
-                <a16:creationId xmlns:a16="http://schemas.microsoft.com/office/drawing/2014/main" id="{C47FCCEB-4590-9061-E34F-031998B96340}"/>
-              </a:ext>
-            </a:extLst>
-          </p:cNvPr>
-          <p:cNvPicPr>
-            <a:picLocks noChangeAspect="1"/>
-          </p:cNvPicPr>
-          <p:nvPr/>
-        </p:nvPicPr>
-        <p:blipFill>
-          <a:blip r:embed="rId3"/>
-          <a:stretch>
-            <a:fillRect/>
-          </a:stretch>
-        </p:blipFill>
-        <p:spPr>
-          <a:xfrm>
-            <a:off x="4700638" y="3660550"/>
-            <a:ext cx="4285555" cy="2603090"/>
-          </a:xfrm>
-          <a:prstGeom prst="rect">
-            <a:avLst/>
-          </a:prstGeom>
-        </p:spPr>
-      </p:pic>
     </p:spTree>
   </p:cSld>
   <p:clrMapOvr>

</xml_diff>